<commit_message>
docs: fold the classroom findings into the Review 1 material
The frame-filter slide gains the settle step as an explicit stage, with
the reason beside it: a teacher walking past was triggering uploads.

The trial slide now carries all seven defects rather than four, and
names the seventh — the fixes were never deployed, so the live service
kept serving pre-fix code. That is the most useful thing in the deck: a
commit is not a release.

The cost line no longer quotes a number that is no longer true. It
states what was measured and what changed: context per note update is
capped at 8,000 characters, down from 48,000, and the per-hour figure is
being re-measured rather than projected. Test counts updated to 97
Android and 36 backend.

Co-Authored-By: Claude Opus 5 <noreply@anthropic.com>
</commit_message>
<xml_diff>
--- a/outputs/VoxBox_Review1_Scope.pptx
+++ b/outputs/VoxBox_Review1_Scope.pptx
@@ -150,7 +150,7 @@
     </p:spTree>
     <p:extLst>
       <p:ext uri="{BB962C8B-B14F-4D97-AF65-F5344CB8AC3E}">
-        <p14:creationId xmlns:p14="http://schemas.microsoft.com/office/powerpoint/2010/main" val="674783762"/>
+        <p14:creationId xmlns:p14="http://schemas.microsoft.com/office/powerpoint/2010/main" val="4250301537"/>
       </p:ext>
     </p:extLst>
   </p:cSld>
@@ -557,7 +557,7 @@
           <a:p>
             <a:r>
               <a:rPr lang="en-US" dirty="0"/>
-              <a:t>Say this out loud rather than hiding it. A working test-and-fix loop is worth more at review 1 than a demo that happens to go well. The timeout one shows you treat latency as a correctness property.</a:t>
+              <a:t>Say this out loud rather than hiding it. A working test-and-fix loop is worth more at review 1 than a demo that happens to go well. Two of these are the strongest answers you have: the timeout shows you treat latency as a correctness property, and the deployment gap shows you check the running system rather than assuming a commit is a release.</a:t>
             </a:r>
           </a:p>
         </p:txBody>
@@ -1253,7 +1253,7 @@
           <a:p>
             <a:r>
               <a:rPr lang="en-US" dirty="0"/>
-              <a:t>This is the answer to 'is it just a wrapper'. The filter is entirely mine, runs on-device, and is the single biggest reason running cost is small. Note-worthy: exposure compensation is unit-tested — a global brightness change must be rejected.</a:t>
+              <a:t>This is the answer to 'is it just a wrapper'. The filter is entirely mine, runs on-device, and is the single biggest reason running cost is small. The settle step came directly from a classroom trial: the teacher moving was triggering uploads. Five unit tests cover it, including a person walking across the board and a projector slide change, which must be treated differently.</a:t>
             </a:r>
           </a:p>
         </p:txBody>
@@ -3484,7 +3484,7 @@
                 <a:ea typeface="Calibri" pitchFamily="34" charset="-122"/>
                 <a:cs typeface="Calibri" pitchFamily="34" charset="-120"/>
               </a:rPr>
-              <a:t>88 Android tests across 28 suites · 30 backend tests · 0 lint errors</a:t>
+              <a:t>97 Android tests across 29 suites · 36 backend tests · 0 lint errors</a:t>
             </a:r>
             <a:endParaRPr lang="en-US" sz="1150" dirty="0"/>
           </a:p>
@@ -3937,7 +3937,7 @@
                 <a:ea typeface="Calibri" pitchFamily="34" charset="-122"/>
                 <a:cs typeface="Calibri" pitchFamily="34" charset="-120"/>
               </a:rPr>
-              <a:t>Real-lecture trial</a:t>
+              <a:t>Real-lecture trials</a:t>
             </a:r>
             <a:endParaRPr lang="en-US" sz="1350" dirty="0"/>
           </a:p>
@@ -3976,7 +3976,7 @@
                 <a:ea typeface="Calibri" pitchFamily="34" charset="-122"/>
                 <a:cs typeface="Calibri" pitchFamily="34" charset="-120"/>
               </a:rPr>
-              <a:t>One algebra segment across 3 board states: a complete note, and 4 defects exposed</a:t>
+              <a:t>A YouTube segment and a live class: 7 defects exposed, all 7 fixed and covered by tests</a:t>
             </a:r>
             <a:endParaRPr lang="en-US" sz="1150" dirty="0"/>
           </a:p>
@@ -4015,7 +4015,7 @@
                 <a:ea typeface="Calibri" pitchFamily="34" charset="-122"/>
                 <a:cs typeface="Calibri" pitchFamily="34" charset="-120"/>
               </a:rPr>
-              <a:t>1 RUN</a:t>
+              <a:t>2 RUNS</a:t>
             </a:r>
             <a:endParaRPr lang="en-US" sz="1100" dirty="0"/>
           </a:p>
@@ -4101,7 +4101,7 @@
                 <a:ea typeface="Calibri" pitchFamily="34" charset="-122"/>
                 <a:cs typeface="Calibri" pitchFamily="34" charset="-120"/>
               </a:rPr>
-              <a:t>Accuracy measurement</a:t>
+              <a:t>Accuracy and cost re-measurement</a:t>
             </a:r>
             <a:endParaRPr lang="en-US" sz="1350" dirty="0"/>
           </a:p>
@@ -4140,7 +4140,7 @@
                 <a:ea typeface="Calibri" pitchFamily="34" charset="-122"/>
                 <a:cs typeface="Calibri" pitchFamily="34" charset="-120"/>
               </a:rPr>
-              <a:t>Word error rate, diarization, OCR, crop IoU on a labelled corpus</a:t>
+              <a:t>Word error rate, diarization, OCR, crop IoU — and cost, on a labelled corpus</a:t>
             </a:r>
             <a:endParaRPr lang="en-US" sz="1150" dirty="0"/>
           </a:p>
@@ -4218,7 +4218,7 @@
                 <a:ea typeface="Calibri" pitchFamily="34" charset="-122"/>
                 <a:cs typeface="Calibri" pitchFamily="34" charset="-120"/>
               </a:rPr>
-              <a:t>Measured running cost: approximately $0.18 per lecture-hour, under a hard daily cap enforced by the server.</a:t>
+              <a:t>Cost per note update fell 6× — forwarded context is now capped at 8,000 characters, not 48,000. The $0.18 lecture-hour is being re-measured.</a:t>
             </a:r>
             <a:endParaRPr lang="en-US" sz="1300" dirty="0"/>
           </a:p>
@@ -4445,7 +4445,7 @@
                 <a:ea typeface="Cambria" pitchFamily="34" charset="-122"/>
                 <a:cs typeface="Cambria" pitchFamily="34" charset="-120"/>
               </a:rPr>
-              <a:t>Real-lecture trial: four defects found and resolved</a:t>
+              <a:t>Testing in a real classroom found seven defects</a:t>
             </a:r>
             <a:endParaRPr lang="en-US" sz="3400" dirty="0"/>
           </a:p>
@@ -4484,7 +4484,7 @@
                 <a:ea typeface="Calibri" pitchFamily="34" charset="-122"/>
                 <a:cs typeface="Calibri" pitchFamily="34" charset="-120"/>
               </a:rPr>
-              <a:t>A 2.5-minute algebra segment across three board states — every defect is now fixed</a:t>
+              <a:t>Two trials — a recorded lecture and a live class. All seven are fixed and covered by tests.</a:t>
             </a:r>
             <a:endParaRPr lang="en-US" sz="1400" dirty="0"/>
           </a:p>
@@ -4498,12 +4498,12 @@
         </p:nvSpPr>
         <p:spPr>
           <a:xfrm>
-            <a:off x="566928" y="1719072"/>
-            <a:ext cx="5431536" cy="2066544"/>
+            <a:off x="566928" y="1627632"/>
+            <a:ext cx="5431536" cy="1298448"/>
           </a:xfrm>
           <a:prstGeom prst="roundRect">
             <a:avLst>
-              <a:gd name="adj" fmla="val 3982"/>
+              <a:gd name="adj" fmla="val 6338"/>
             </a:avLst>
           </a:prstGeom>
           <a:solidFill>
@@ -4525,24 +4525,24 @@
         </p:nvSpPr>
         <p:spPr>
           <a:xfrm>
-            <a:off x="841248" y="1938528"/>
-            <a:ext cx="4892040" cy="292608"/>
-          </a:xfrm>
-          <a:prstGeom prst="rect">
-            <a:avLst/>
-          </a:prstGeom>
-          <a:noFill/>
-          <a:ln/>
-        </p:spPr>
-        <p:txBody>
-          <a:bodyPr wrap="square" lIns="0" tIns="0" rIns="0" bIns="0" rtlCol="0" anchor="ctr"/>
-          <a:lstStyle/>
-          <a:p>
-            <a:pPr marL="0" indent="0">
-              <a:buNone/>
-            </a:pPr>
-            <a:r>
-              <a:rPr lang="en-US" sz="1400" b="1" dirty="0">
+            <a:off x="822960" y="1755648"/>
+            <a:ext cx="4937760" cy="274320"/>
+          </a:xfrm>
+          <a:prstGeom prst="rect">
+            <a:avLst/>
+          </a:prstGeom>
+          <a:noFill/>
+          <a:ln/>
+        </p:spPr>
+        <p:txBody>
+          <a:bodyPr wrap="square" lIns="0" tIns="0" rIns="0" bIns="0" rtlCol="0" anchor="t"/>
+          <a:lstStyle/>
+          <a:p>
+            <a:pPr marL="0" indent="0">
+              <a:buNone/>
+            </a:pPr>
+            <a:r>
+              <a:rPr lang="en-US" sz="1300" b="1" dirty="0">
                 <a:solidFill>
                   <a:srgbClr val="9E3B3B"/>
                 </a:solidFill>
@@ -4552,7 +4552,7 @@
               </a:rPr>
               <a:t>Note generation timed out</a:t>
             </a:r>
-            <a:endParaRPr lang="en-US" sz="1400" dirty="0"/>
+            <a:endParaRPr lang="en-US" sz="1300" dirty="0"/>
           </a:p>
         </p:txBody>
       </p:sp>
@@ -4564,24 +4564,24 @@
         </p:nvSpPr>
         <p:spPr>
           <a:xfrm>
-            <a:off x="841248" y="2322576"/>
-            <a:ext cx="4892040" cy="731520"/>
-          </a:xfrm>
-          <a:prstGeom prst="rect">
-            <a:avLst/>
-          </a:prstGeom>
-          <a:noFill/>
-          <a:ln/>
-        </p:spPr>
-        <p:txBody>
-          <a:bodyPr wrap="square" lIns="0" tIns="0" rIns="0" bIns="0" rtlCol="0" anchor="ctr"/>
-          <a:lstStyle/>
-          <a:p>
-            <a:pPr marL="0" indent="0">
-              <a:buNone/>
-            </a:pPr>
-            <a:r>
-              <a:rPr lang="en-US" sz="1150" dirty="0">
+            <a:off x="822960" y="2048256"/>
+            <a:ext cx="4937760" cy="548640"/>
+          </a:xfrm>
+          <a:prstGeom prst="rect">
+            <a:avLst/>
+          </a:prstGeom>
+          <a:noFill/>
+          <a:ln/>
+        </p:spPr>
+        <p:txBody>
+          <a:bodyPr wrap="square" lIns="0" tIns="0" rIns="0" bIns="0" rtlCol="0" anchor="t"/>
+          <a:lstStyle/>
+          <a:p>
+            <a:pPr marL="0" indent="0">
+              <a:buNone/>
+            </a:pPr>
+            <a:r>
+              <a:rPr lang="en-US" sz="1050" dirty="0">
                 <a:solidFill>
                   <a:srgbClr val="5B6180"/>
                 </a:solidFill>
@@ -4589,9 +4589,9 @@
                 <a:ea typeface="Calibri" pitchFamily="34" charset="-122"/>
                 <a:cs typeface="Calibri" pitchFamily="34" charset="-120"/>
               </a:rPr>
-              <a:t>The selected model handled a small request in 0.7 s, but exceeded the 90 s timeout once the note had grown.</a:t>
-            </a:r>
-            <a:endParaRPr lang="en-US" sz="1150" dirty="0"/>
+              <a:t>The chosen model handled a small request in 0.7 s but exceeded the 90 s timeout once the note had grown.</a:t>
+            </a:r>
+            <a:endParaRPr lang="en-US" sz="1050" dirty="0"/>
           </a:p>
         </p:txBody>
       </p:sp>
@@ -4603,24 +4603,24 @@
         </p:nvSpPr>
         <p:spPr>
           <a:xfrm>
-            <a:off x="841248" y="3108960"/>
-            <a:ext cx="4892040" cy="548640"/>
-          </a:xfrm>
-          <a:prstGeom prst="rect">
-            <a:avLst/>
-          </a:prstGeom>
-          <a:noFill/>
-          <a:ln/>
-        </p:spPr>
-        <p:txBody>
-          <a:bodyPr wrap="square" lIns="0" tIns="0" rIns="0" bIns="0" rtlCol="0" anchor="ctr"/>
-          <a:lstStyle/>
-          <a:p>
-            <a:pPr marL="0" indent="0">
-              <a:buNone/>
-            </a:pPr>
-            <a:r>
-              <a:rPr lang="en-US" sz="1150" b="1" dirty="0">
+            <a:off x="822960" y="2560320"/>
+            <a:ext cx="4937760" cy="310896"/>
+          </a:xfrm>
+          <a:prstGeom prst="rect">
+            <a:avLst/>
+          </a:prstGeom>
+          <a:noFill/>
+          <a:ln/>
+        </p:spPr>
+        <p:txBody>
+          <a:bodyPr wrap="square" lIns="0" tIns="0" rIns="0" bIns="0" rtlCol="0" anchor="t"/>
+          <a:lstStyle/>
+          <a:p>
+            <a:pPr marL="0" indent="0">
+              <a:buNone/>
+            </a:pPr>
+            <a:r>
+              <a:rPr lang="en-US" sz="1050" b="1" dirty="0">
                 <a:solidFill>
                   <a:srgbClr val="2C6E49"/>
                 </a:solidFill>
@@ -4628,9 +4628,9 @@
                 <a:ea typeface="Calibri" pitchFamily="34" charset="-122"/>
                 <a:cs typeface="Calibri" pitchFamily="34" charset="-120"/>
               </a:rPr>
-              <a:t>→  Re-measured at realistic scale; replaced with a model ~60× faster</a:t>
-            </a:r>
-            <a:endParaRPr lang="en-US" sz="1150" dirty="0"/>
+              <a:t>→  Re-measured at scale; replaced with a model ~60× faster</a:t>
+            </a:r>
+            <a:endParaRPr lang="en-US" sz="1050" dirty="0"/>
           </a:p>
         </p:txBody>
       </p:sp>
@@ -4642,12 +4642,12 @@
         </p:nvSpPr>
         <p:spPr>
           <a:xfrm>
-            <a:off x="6190488" y="1719072"/>
-            <a:ext cx="5431536" cy="2066544"/>
+            <a:off x="6190488" y="1627632"/>
+            <a:ext cx="5431536" cy="1298448"/>
           </a:xfrm>
           <a:prstGeom prst="roundRect">
             <a:avLst>
-              <a:gd name="adj" fmla="val 3982"/>
+              <a:gd name="adj" fmla="val 6338"/>
             </a:avLst>
           </a:prstGeom>
           <a:solidFill>
@@ -4669,24 +4669,24 @@
         </p:nvSpPr>
         <p:spPr>
           <a:xfrm>
-            <a:off x="6464808" y="1938528"/>
-            <a:ext cx="4892040" cy="292608"/>
-          </a:xfrm>
-          <a:prstGeom prst="rect">
-            <a:avLst/>
-          </a:prstGeom>
-          <a:noFill/>
-          <a:ln/>
-        </p:spPr>
-        <p:txBody>
-          <a:bodyPr wrap="square" lIns="0" tIns="0" rIns="0" bIns="0" rtlCol="0" anchor="ctr"/>
-          <a:lstStyle/>
-          <a:p>
-            <a:pPr marL="0" indent="0">
-              <a:buNone/>
-            </a:pPr>
-            <a:r>
-              <a:rPr lang="en-US" sz="1400" b="1" dirty="0">
+            <a:off x="6446520" y="1755648"/>
+            <a:ext cx="4937760" cy="274320"/>
+          </a:xfrm>
+          <a:prstGeom prst="rect">
+            <a:avLst/>
+          </a:prstGeom>
+          <a:noFill/>
+          <a:ln/>
+        </p:spPr>
+        <p:txBody>
+          <a:bodyPr wrap="square" lIns="0" tIns="0" rIns="0" bIns="0" rtlCol="0" anchor="t"/>
+          <a:lstStyle/>
+          <a:p>
+            <a:pPr marL="0" indent="0">
+              <a:buNone/>
+            </a:pPr>
+            <a:r>
+              <a:rPr lang="en-US" sz="1300" b="1" dirty="0">
                 <a:solidFill>
                   <a:srgbClr val="9E3B3B"/>
                 </a:solidFill>
@@ -4696,7 +4696,7 @@
               </a:rPr>
               <a:t>Formulas rendered as raw text</a:t>
             </a:r>
-            <a:endParaRPr lang="en-US" sz="1400" dirty="0"/>
+            <a:endParaRPr lang="en-US" sz="1300" dirty="0"/>
           </a:p>
         </p:txBody>
       </p:sp>
@@ -4708,24 +4708,24 @@
         </p:nvSpPr>
         <p:spPr>
           <a:xfrm>
-            <a:off x="6464808" y="2322576"/>
-            <a:ext cx="4892040" cy="731520"/>
-          </a:xfrm>
-          <a:prstGeom prst="rect">
-            <a:avLst/>
-          </a:prstGeom>
-          <a:noFill/>
-          <a:ln/>
-        </p:spPr>
-        <p:txBody>
-          <a:bodyPr wrap="square" lIns="0" tIns="0" rIns="0" bIns="0" rtlCol="0" anchor="ctr"/>
-          <a:lstStyle/>
-          <a:p>
-            <a:pPr marL="0" indent="0">
-              <a:buNone/>
-            </a:pPr>
-            <a:r>
-              <a:rPr lang="en-US" sz="1150" dirty="0">
+            <a:off x="6446520" y="2048256"/>
+            <a:ext cx="4937760" cy="548640"/>
+          </a:xfrm>
+          <a:prstGeom prst="rect">
+            <a:avLst/>
+          </a:prstGeom>
+          <a:noFill/>
+          <a:ln/>
+        </p:spPr>
+        <p:txBody>
+          <a:bodyPr wrap="square" lIns="0" tIns="0" rIns="0" bIns="0" rtlCol="0" anchor="t"/>
+          <a:lstStyle/>
+          <a:p>
+            <a:pPr marL="0" indent="0">
+              <a:buNone/>
+            </a:pPr>
+            <a:r>
+              <a:rPr lang="en-US" sz="1050" dirty="0">
                 <a:solidFill>
                   <a:srgbClr val="5B6180"/>
                 </a:solidFill>
@@ -4733,9 +4733,9 @@
                 <a:ea typeface="Calibri" pitchFamily="34" charset="-122"/>
                 <a:cs typeface="Calibri" pitchFamily="34" charset="-120"/>
               </a:rPr>
-              <a:t>Output mixed LaTeX delimiter styles that the Markdown reader does not support.</a:t>
-            </a:r>
-            <a:endParaRPr lang="en-US" sz="1150" dirty="0"/>
+              <a:t>The model mixed LaTeX delimiter styles the Markdown reader does not support.</a:t>
+            </a:r>
+            <a:endParaRPr lang="en-US" sz="1050" dirty="0"/>
           </a:p>
         </p:txBody>
       </p:sp>
@@ -4747,24 +4747,24 @@
         </p:nvSpPr>
         <p:spPr>
           <a:xfrm>
-            <a:off x="6464808" y="3108960"/>
-            <a:ext cx="4892040" cy="548640"/>
-          </a:xfrm>
-          <a:prstGeom prst="rect">
-            <a:avLst/>
-          </a:prstGeom>
-          <a:noFill/>
-          <a:ln/>
-        </p:spPr>
-        <p:txBody>
-          <a:bodyPr wrap="square" lIns="0" tIns="0" rIns="0" bIns="0" rtlCol="0" anchor="ctr"/>
-          <a:lstStyle/>
-          <a:p>
-            <a:pPr marL="0" indent="0">
-              <a:buNone/>
-            </a:pPr>
-            <a:r>
-              <a:rPr lang="en-US" sz="1150" b="1" dirty="0">
+            <a:off x="6446520" y="2560320"/>
+            <a:ext cx="4937760" cy="310896"/>
+          </a:xfrm>
+          <a:prstGeom prst="rect">
+            <a:avLst/>
+          </a:prstGeom>
+          <a:noFill/>
+          <a:ln/>
+        </p:spPr>
+        <p:txBody>
+          <a:bodyPr wrap="square" lIns="0" tIns="0" rIns="0" bIns="0" rtlCol="0" anchor="t"/>
+          <a:lstStyle/>
+          <a:p>
+            <a:pPr marL="0" indent="0">
+              <a:buNone/>
+            </a:pPr>
+            <a:r>
+              <a:rPr lang="en-US" sz="1050" b="1" dirty="0">
                 <a:solidFill>
                   <a:srgbClr val="2C6E49"/>
                 </a:solidFill>
@@ -4772,9 +4772,9 @@
                 <a:ea typeface="Calibri" pitchFamily="34" charset="-122"/>
                 <a:cs typeface="Calibri" pitchFamily="34" charset="-120"/>
               </a:rPr>
-              <a:t>→  The server normalises delimiters to the forms the reader renders</a:t>
-            </a:r>
-            <a:endParaRPr lang="en-US" sz="1150" dirty="0"/>
+              <a:t>→  Server rewrites every delimiter form to the two the reader renders</a:t>
+            </a:r>
+            <a:endParaRPr lang="en-US" sz="1050" dirty="0"/>
           </a:p>
         </p:txBody>
       </p:sp>
@@ -4786,12 +4786,12 @@
         </p:nvSpPr>
         <p:spPr>
           <a:xfrm>
-            <a:off x="566928" y="3986784"/>
-            <a:ext cx="5431536" cy="2066544"/>
+            <a:off x="566928" y="3090672"/>
+            <a:ext cx="5431536" cy="1298448"/>
           </a:xfrm>
           <a:prstGeom prst="roundRect">
             <a:avLst>
-              <a:gd name="adj" fmla="val 3982"/>
+              <a:gd name="adj" fmla="val 6338"/>
             </a:avLst>
           </a:prstGeom>
           <a:solidFill>
@@ -4813,24 +4813,24 @@
         </p:nvSpPr>
         <p:spPr>
           <a:xfrm>
-            <a:off x="841248" y="4206240"/>
-            <a:ext cx="4892040" cy="292608"/>
-          </a:xfrm>
-          <a:prstGeom prst="rect">
-            <a:avLst/>
-          </a:prstGeom>
-          <a:noFill/>
-          <a:ln/>
-        </p:spPr>
-        <p:txBody>
-          <a:bodyPr wrap="square" lIns="0" tIns="0" rIns="0" bIns="0" rtlCol="0" anchor="ctr"/>
-          <a:lstStyle/>
-          <a:p>
-            <a:pPr marL="0" indent="0">
-              <a:buNone/>
-            </a:pPr>
-            <a:r>
-              <a:rPr lang="en-US" sz="1400" b="1" dirty="0">
+            <a:off x="822960" y="3218688"/>
+            <a:ext cx="4937760" cy="274320"/>
+          </a:xfrm>
+          <a:prstGeom prst="rect">
+            <a:avLst/>
+          </a:prstGeom>
+          <a:noFill/>
+          <a:ln/>
+        </p:spPr>
+        <p:txBody>
+          <a:bodyPr wrap="square" lIns="0" tIns="0" rIns="0" bIns="0" rtlCol="0" anchor="t"/>
+          <a:lstStyle/>
+          <a:p>
+            <a:pPr marL="0" indent="0">
+              <a:buNone/>
+            </a:pPr>
+            <a:r>
+              <a:rPr lang="en-US" sz="1300" b="1" dirty="0">
                 <a:solidFill>
                   <a:srgbClr val="9E3B3B"/>
                 </a:solidFill>
@@ -4840,7 +4840,7 @@
               </a:rPr>
               <a:t>Far too much content</a:t>
             </a:r>
-            <a:endParaRPr lang="en-US" sz="1400" dirty="0"/>
+            <a:endParaRPr lang="en-US" sz="1300" dirty="0"/>
           </a:p>
         </p:txBody>
       </p:sp>
@@ -4852,24 +4852,24 @@
         </p:nvSpPr>
         <p:spPr>
           <a:xfrm>
-            <a:off x="841248" y="4590288"/>
-            <a:ext cx="4892040" cy="731520"/>
-          </a:xfrm>
-          <a:prstGeom prst="rect">
-            <a:avLst/>
-          </a:prstGeom>
-          <a:noFill/>
-          <a:ln/>
-        </p:spPr>
-        <p:txBody>
-          <a:bodyPr wrap="square" lIns="0" tIns="0" rIns="0" bIns="0" rtlCol="0" anchor="ctr"/>
-          <a:lstStyle/>
-          <a:p>
-            <a:pPr marL="0" indent="0">
-              <a:buNone/>
-            </a:pPr>
-            <a:r>
-              <a:rPr lang="en-US" sz="1150" dirty="0">
+            <a:off x="822960" y="3511296"/>
+            <a:ext cx="4937760" cy="548640"/>
+          </a:xfrm>
+          <a:prstGeom prst="rect">
+            <a:avLst/>
+          </a:prstGeom>
+          <a:noFill/>
+          <a:ln/>
+        </p:spPr>
+        <p:txBody>
+          <a:bodyPr wrap="square" lIns="0" tIns="0" rIns="0" bIns="0" rtlCol="0" anchor="t"/>
+          <a:lstStyle/>
+          <a:p>
+            <a:pPr marL="0" indent="0">
+              <a:buNone/>
+            </a:pPr>
+            <a:r>
+              <a:rPr lang="en-US" sz="1050" dirty="0">
                 <a:solidFill>
                   <a:srgbClr val="5B6180"/>
                 </a:solidFill>
@@ -4879,7 +4879,7 @@
               </a:rPr>
               <a:t>A short concept produced several pages of expansion.</a:t>
             </a:r>
-            <a:endParaRPr lang="en-US" sz="1150" dirty="0"/>
+            <a:endParaRPr lang="en-US" sz="1050" dirty="0"/>
           </a:p>
         </p:txBody>
       </p:sp>
@@ -4891,24 +4891,24 @@
         </p:nvSpPr>
         <p:spPr>
           <a:xfrm>
-            <a:off x="841248" y="5376672"/>
-            <a:ext cx="4892040" cy="548640"/>
-          </a:xfrm>
-          <a:prstGeom prst="rect">
-            <a:avLst/>
-          </a:prstGeom>
-          <a:noFill/>
-          <a:ln/>
-        </p:spPr>
-        <p:txBody>
-          <a:bodyPr wrap="square" lIns="0" tIns="0" rIns="0" bIns="0" rtlCol="0" anchor="ctr"/>
-          <a:lstStyle/>
-          <a:p>
-            <a:pPr marL="0" indent="0">
-              <a:buNone/>
-            </a:pPr>
-            <a:r>
-              <a:rPr lang="en-US" sz="1150" b="1" dirty="0">
+            <a:off x="822960" y="4023360"/>
+            <a:ext cx="4937760" cy="310896"/>
+          </a:xfrm>
+          <a:prstGeom prst="rect">
+            <a:avLst/>
+          </a:prstGeom>
+          <a:noFill/>
+          <a:ln/>
+        </p:spPr>
+        <p:txBody>
+          <a:bodyPr wrap="square" lIns="0" tIns="0" rIns="0" bIns="0" rtlCol="0" anchor="t"/>
+          <a:lstStyle/>
+          <a:p>
+            <a:pPr marL="0" indent="0">
+              <a:buNone/>
+            </a:pPr>
+            <a:r>
+              <a:rPr lang="en-US" sz="1050" b="1" dirty="0">
                 <a:solidFill>
                   <a:srgbClr val="2C6E49"/>
                 </a:solidFill>
@@ -4916,9 +4916,9 @@
                 <a:ea typeface="Calibri" pitchFamily="34" charset="-122"/>
                 <a:cs typeface="Calibri" pitchFamily="34" charset="-120"/>
               </a:rPr>
-              <a:t>→  Added short / balanced / elaborate levels and a custom instruction</a:t>
-            </a:r>
-            <a:endParaRPr lang="en-US" sz="1150" dirty="0"/>
+              <a:t>→  Concise is now the default, with a custom instruction field</a:t>
+            </a:r>
+            <a:endParaRPr lang="en-US" sz="1050" dirty="0"/>
           </a:p>
         </p:txBody>
       </p:sp>
@@ -4930,12 +4930,12 @@
         </p:nvSpPr>
         <p:spPr>
           <a:xfrm>
-            <a:off x="6190488" y="3986784"/>
-            <a:ext cx="5431536" cy="2066544"/>
+            <a:off x="6190488" y="3090672"/>
+            <a:ext cx="5431536" cy="1298448"/>
           </a:xfrm>
           <a:prstGeom prst="roundRect">
             <a:avLst>
-              <a:gd name="adj" fmla="val 3982"/>
+              <a:gd name="adj" fmla="val 6338"/>
             </a:avLst>
           </a:prstGeom>
           <a:solidFill>
@@ -4957,24 +4957,24 @@
         </p:nvSpPr>
         <p:spPr>
           <a:xfrm>
-            <a:off x="6464808" y="4206240"/>
-            <a:ext cx="4892040" cy="292608"/>
-          </a:xfrm>
-          <a:prstGeom prst="rect">
-            <a:avLst/>
-          </a:prstGeom>
-          <a:noFill/>
-          <a:ln/>
-        </p:spPr>
-        <p:txBody>
-          <a:bodyPr wrap="square" lIns="0" tIns="0" rIns="0" bIns="0" rtlCol="0" anchor="ctr"/>
-          <a:lstStyle/>
-          <a:p>
-            <a:pPr marL="0" indent="0">
-              <a:buNone/>
-            </a:pPr>
-            <a:r>
-              <a:rPr lang="en-US" sz="1400" b="1" dirty="0">
+            <a:off x="6446520" y="3218688"/>
+            <a:ext cx="4937760" cy="274320"/>
+          </a:xfrm>
+          <a:prstGeom prst="rect">
+            <a:avLst/>
+          </a:prstGeom>
+          <a:noFill/>
+          <a:ln/>
+        </p:spPr>
+        <p:txBody>
+          <a:bodyPr wrap="square" lIns="0" tIns="0" rIns="0" bIns="0" rtlCol="0" anchor="t"/>
+          <a:lstStyle/>
+          <a:p>
+            <a:pPr marL="0" indent="0">
+              <a:buNone/>
+            </a:pPr>
+            <a:r>
+              <a:rPr lang="en-US" sz="1300" b="1" dirty="0">
                 <a:solidFill>
                   <a:srgbClr val="9E3B3B"/>
                 </a:solidFill>
@@ -4984,7 +4984,7 @@
               </a:rPr>
               <a:t>An invented example appeared</a:t>
             </a:r>
-            <a:endParaRPr lang="en-US" sz="1400" dirty="0"/>
+            <a:endParaRPr lang="en-US" sz="1300" dirty="0"/>
           </a:p>
         </p:txBody>
       </p:sp>
@@ -4996,71 +4996,409 @@
         </p:nvSpPr>
         <p:spPr>
           <a:xfrm>
-            <a:off x="6464808" y="4590288"/>
-            <a:ext cx="4892040" cy="731520"/>
-          </a:xfrm>
-          <a:prstGeom prst="rect">
-            <a:avLst/>
-          </a:prstGeom>
-          <a:noFill/>
-          <a:ln/>
-        </p:spPr>
-        <p:txBody>
-          <a:bodyPr wrap="square" lIns="0" tIns="0" rIns="0" bIns="0" rtlCol="0" anchor="ctr"/>
-          <a:lstStyle/>
-          <a:p>
-            <a:pPr marL="0" indent="0">
-              <a:buNone/>
-            </a:pPr>
+            <a:off x="6446520" y="3511296"/>
+            <a:ext cx="4937760" cy="548640"/>
+          </a:xfrm>
+          <a:prstGeom prst="rect">
+            <a:avLst/>
+          </a:prstGeom>
+          <a:noFill/>
+          <a:ln/>
+        </p:spPr>
+        <p:txBody>
+          <a:bodyPr wrap="square" lIns="0" tIns="0" rIns="0" bIns="0" rtlCol="0" anchor="t"/>
+          <a:lstStyle/>
+          <a:p>
+            <a:pPr marL="0" indent="0">
+              <a:buNone/>
+            </a:pPr>
+            <a:r>
+              <a:rPr lang="en-US" sz="1050" dirty="0">
+                <a:solidFill>
+                  <a:srgbClr val="5B6180"/>
+                </a:solidFill>
+                <a:latin typeface="Calibri" pitchFamily="34" charset="0"/>
+                <a:ea typeface="Calibri" pitchFamily="34" charset="-122"/>
+                <a:cs typeface="Calibri" pitchFamily="34" charset="-120"/>
+              </a:rPr>
+              <a:t>A worked example was in neither the board nor the transcript.</a:t>
+            </a:r>
+            <a:endParaRPr lang="en-US" sz="1050" dirty="0"/>
+          </a:p>
+        </p:txBody>
+      </p:sp>
+      <p:sp>
+        <p:nvSpPr>
+          <p:cNvPr id="21" name="Text 19"/>
+          <p:cNvSpPr/>
+          <p:nvPr/>
+        </p:nvSpPr>
+        <p:spPr>
+          <a:xfrm>
+            <a:off x="6446520" y="4023360"/>
+            <a:ext cx="4937760" cy="310896"/>
+          </a:xfrm>
+          <a:prstGeom prst="rect">
+            <a:avLst/>
+          </a:prstGeom>
+          <a:noFill/>
+          <a:ln/>
+        </p:spPr>
+        <p:txBody>
+          <a:bodyPr wrap="square" lIns="0" tIns="0" rIns="0" bIns="0" rtlCol="0" anchor="t"/>
+          <a:lstStyle/>
+          <a:p>
+            <a:pPr marL="0" indent="0">
+              <a:buNone/>
+            </a:pPr>
+            <a:r>
+              <a:rPr lang="en-US" sz="1050" b="1" dirty="0">
+                <a:solidFill>
+                  <a:srgbClr val="2C6E49"/>
+                </a:solidFill>
+                <a:latin typeface="Calibri" pitchFamily="34" charset="0"/>
+                <a:ea typeface="Calibri" pitchFamily="34" charset="-122"/>
+                <a:cs typeface="Calibri" pitchFamily="34" charset="-120"/>
+              </a:rPr>
+              <a:t>→  The prompt now prohibits examples absent from the evidence</a:t>
+            </a:r>
+            <a:endParaRPr lang="en-US" sz="1050" dirty="0"/>
+          </a:p>
+        </p:txBody>
+      </p:sp>
+      <p:sp>
+        <p:nvSpPr>
+          <p:cNvPr id="22" name="Shape 20"/>
+          <p:cNvSpPr/>
+          <p:nvPr/>
+        </p:nvSpPr>
+        <p:spPr>
+          <a:xfrm>
+            <a:off x="566928" y="4553712"/>
+            <a:ext cx="5431536" cy="1298448"/>
+          </a:xfrm>
+          <a:prstGeom prst="roundRect">
+            <a:avLst>
+              <a:gd name="adj" fmla="val 6338"/>
+            </a:avLst>
+          </a:prstGeom>
+          <a:solidFill>
+            <a:srgbClr val="FFFFFF"/>
+          </a:solidFill>
+          <a:ln w="12700">
+            <a:solidFill>
+              <a:srgbClr val="E2E7F0"/>
+            </a:solidFill>
+            <a:prstDash val="solid"/>
+          </a:ln>
+        </p:spPr>
+      </p:sp>
+      <p:sp>
+        <p:nvSpPr>
+          <p:cNvPr id="23" name="Text 21"/>
+          <p:cNvSpPr/>
+          <p:nvPr/>
+        </p:nvSpPr>
+        <p:spPr>
+          <a:xfrm>
+            <a:off x="822960" y="4681728"/>
+            <a:ext cx="4937760" cy="274320"/>
+          </a:xfrm>
+          <a:prstGeom prst="rect">
+            <a:avLst/>
+          </a:prstGeom>
+          <a:noFill/>
+          <a:ln/>
+        </p:spPr>
+        <p:txBody>
+          <a:bodyPr wrap="square" lIns="0" tIns="0" rIns="0" bIns="0" rtlCol="0" anchor="t"/>
+          <a:lstStyle/>
+          <a:p>
+            <a:pPr marL="0" indent="0">
+              <a:buNone/>
+            </a:pPr>
+            <a:r>
+              <a:rPr lang="en-US" sz="1300" b="1" dirty="0">
+                <a:solidFill>
+                  <a:srgbClr val="9E3B3B"/>
+                </a:solidFill>
+                <a:latin typeface="Calibri" pitchFamily="34" charset="0"/>
+                <a:ea typeface="Calibri" pitchFamily="34" charset="-122"/>
+                <a:cs typeface="Calibri" pitchFamily="34" charset="-120"/>
+              </a:rPr>
+              <a:t>Teacher movement triggered uploads</a:t>
+            </a:r>
+            <a:endParaRPr lang="en-US" sz="1300" dirty="0"/>
+          </a:p>
+        </p:txBody>
+      </p:sp>
+      <p:sp>
+        <p:nvSpPr>
+          <p:cNvPr id="24" name="Text 22"/>
+          <p:cNvSpPr/>
+          <p:nvPr/>
+        </p:nvSpPr>
+        <p:spPr>
+          <a:xfrm>
+            <a:off x="822960" y="4974336"/>
+            <a:ext cx="4937760" cy="548640"/>
+          </a:xfrm>
+          <a:prstGeom prst="rect">
+            <a:avLst/>
+          </a:prstGeom>
+          <a:noFill/>
+          <a:ln/>
+        </p:spPr>
+        <p:txBody>
+          <a:bodyPr wrap="square" lIns="0" tIns="0" rIns="0" bIns="0" rtlCol="0" anchor="t"/>
+          <a:lstStyle/>
+          <a:p>
+            <a:pPr marL="0" indent="0">
+              <a:buNone/>
+            </a:pPr>
+            <a:r>
+              <a:rPr lang="en-US" sz="1050" dirty="0">
+                <a:solidFill>
+                  <a:srgbClr val="5B6180"/>
+                </a:solidFill>
+                <a:latin typeface="Calibri" pitchFamily="34" charset="0"/>
+                <a:ea typeface="Calibri" pitchFamily="34" charset="-122"/>
+                <a:cs typeface="Calibri" pitchFamily="34" charset="-120"/>
+              </a:rPr>
+              <a:t>Anyone crossing the camera changed the frame, so the filter paid for a board that had not changed.</a:t>
+            </a:r>
+            <a:endParaRPr lang="en-US" sz="1050" dirty="0"/>
+          </a:p>
+        </p:txBody>
+      </p:sp>
+      <p:sp>
+        <p:nvSpPr>
+          <p:cNvPr id="25" name="Text 23"/>
+          <p:cNvSpPr/>
+          <p:nvPr/>
+        </p:nvSpPr>
+        <p:spPr>
+          <a:xfrm>
+            <a:off x="822960" y="5486400"/>
+            <a:ext cx="4937760" cy="310896"/>
+          </a:xfrm>
+          <a:prstGeom prst="rect">
+            <a:avLst/>
+          </a:prstGeom>
+          <a:noFill/>
+          <a:ln/>
+        </p:spPr>
+        <p:txBody>
+          <a:bodyPr wrap="square" lIns="0" tIns="0" rIns="0" bIns="0" rtlCol="0" anchor="t"/>
+          <a:lstStyle/>
+          <a:p>
+            <a:pPr marL="0" indent="0">
+              <a:buNone/>
+            </a:pPr>
+            <a:r>
+              <a:rPr lang="en-US" sz="1050" b="1" dirty="0">
+                <a:solidFill>
+                  <a:srgbClr val="2C6E49"/>
+                </a:solidFill>
+                <a:latin typeface="Calibri" pitchFamily="34" charset="0"/>
+                <a:ea typeface="Calibri" pitchFamily="34" charset="-122"/>
+                <a:cs typeface="Calibri" pitchFamily="34" charset="-120"/>
+              </a:rPr>
+              <a:t>→  A change must survive to the next sample before it is sent</a:t>
+            </a:r>
+            <a:endParaRPr lang="en-US" sz="1050" dirty="0"/>
+          </a:p>
+        </p:txBody>
+      </p:sp>
+      <p:sp>
+        <p:nvSpPr>
+          <p:cNvPr id="26" name="Shape 24"/>
+          <p:cNvSpPr/>
+          <p:nvPr/>
+        </p:nvSpPr>
+        <p:spPr>
+          <a:xfrm>
+            <a:off x="6190488" y="4553712"/>
+            <a:ext cx="5431536" cy="1298448"/>
+          </a:xfrm>
+          <a:prstGeom prst="roundRect">
+            <a:avLst>
+              <a:gd name="adj" fmla="val 6338"/>
+            </a:avLst>
+          </a:prstGeom>
+          <a:solidFill>
+            <a:srgbClr val="FFFFFF"/>
+          </a:solidFill>
+          <a:ln w="12700">
+            <a:solidFill>
+              <a:srgbClr val="E2E7F0"/>
+            </a:solidFill>
+            <a:prstDash val="solid"/>
+          </a:ln>
+        </p:spPr>
+      </p:sp>
+      <p:sp>
+        <p:nvSpPr>
+          <p:cNvPr id="27" name="Text 25"/>
+          <p:cNvSpPr/>
+          <p:nvPr/>
+        </p:nvSpPr>
+        <p:spPr>
+          <a:xfrm>
+            <a:off x="6446520" y="4681728"/>
+            <a:ext cx="4937760" cy="274320"/>
+          </a:xfrm>
+          <a:prstGeom prst="rect">
+            <a:avLst/>
+          </a:prstGeom>
+          <a:noFill/>
+          <a:ln/>
+        </p:spPr>
+        <p:txBody>
+          <a:bodyPr wrap="square" lIns="0" tIns="0" rIns="0" bIns="0" rtlCol="0" anchor="t"/>
+          <a:lstStyle/>
+          <a:p>
+            <a:pPr marL="0" indent="0">
+              <a:buNone/>
+            </a:pPr>
+            <a:r>
+              <a:rPr lang="en-US" sz="1300" b="1" dirty="0">
+                <a:solidFill>
+                  <a:srgbClr val="9E3B3B"/>
+                </a:solidFill>
+                <a:latin typeface="Calibri" pitchFamily="34" charset="0"/>
+                <a:ea typeface="Calibri" pitchFamily="34" charset="-122"/>
+                <a:cs typeface="Calibri" pitchFamily="34" charset="-120"/>
+              </a:rPr>
+              <a:t>Running cost too high</a:t>
+            </a:r>
+            <a:endParaRPr lang="en-US" sz="1300" dirty="0"/>
+          </a:p>
+        </p:txBody>
+      </p:sp>
+      <p:sp>
+        <p:nvSpPr>
+          <p:cNvPr id="28" name="Text 26"/>
+          <p:cNvSpPr/>
+          <p:nvPr/>
+        </p:nvSpPr>
+        <p:spPr>
+          <a:xfrm>
+            <a:off x="6446520" y="4974336"/>
+            <a:ext cx="4937760" cy="548640"/>
+          </a:xfrm>
+          <a:prstGeom prst="rect">
+            <a:avLst/>
+          </a:prstGeom>
+          <a:noFill/>
+          <a:ln/>
+        </p:spPr>
+        <p:txBody>
+          <a:bodyPr wrap="square" lIns="0" tIns="0" rIns="0" bIns="0" rtlCol="0" anchor="t"/>
+          <a:lstStyle/>
+          <a:p>
+            <a:pPr marL="0" indent="0">
+              <a:buNone/>
+            </a:pPr>
+            <a:r>
+              <a:rPr lang="en-US" sz="1050" dirty="0">
+                <a:solidFill>
+                  <a:srgbClr val="5B6180"/>
+                </a:solidFill>
+                <a:latin typeface="Calibri" pitchFamily="34" charset="0"/>
+                <a:ea typeface="Calibri" pitchFamily="34" charset="-122"/>
+                <a:cs typeface="Calibri" pitchFamily="34" charset="-120"/>
+              </a:rPr>
+              <a:t>48,000 characters of context were re-sent on every note update, ~180 times an hour.</a:t>
+            </a:r>
+            <a:endParaRPr lang="en-US" sz="1050" dirty="0"/>
+          </a:p>
+        </p:txBody>
+      </p:sp>
+      <p:sp>
+        <p:nvSpPr>
+          <p:cNvPr id="29" name="Text 27"/>
+          <p:cNvSpPr/>
+          <p:nvPr/>
+        </p:nvSpPr>
+        <p:spPr>
+          <a:xfrm>
+            <a:off x="6446520" y="5486400"/>
+            <a:ext cx="4937760" cy="310896"/>
+          </a:xfrm>
+          <a:prstGeom prst="rect">
+            <a:avLst/>
+          </a:prstGeom>
+          <a:noFill/>
+          <a:ln/>
+        </p:spPr>
+        <p:txBody>
+          <a:bodyPr wrap="square" lIns="0" tIns="0" rIns="0" bIns="0" rtlCol="0" anchor="t"/>
+          <a:lstStyle/>
+          <a:p>
+            <a:pPr marL="0" indent="0">
+              <a:buNone/>
+            </a:pPr>
+            <a:r>
+              <a:rPr lang="en-US" sz="1050" b="1" dirty="0">
+                <a:solidFill>
+                  <a:srgbClr val="2C6E49"/>
+                </a:solidFill>
+                <a:latin typeface="Calibri" pitchFamily="34" charset="0"/>
+                <a:ea typeface="Calibri" pitchFamily="34" charset="-122"/>
+                <a:cs typeface="Calibri" pitchFamily="34" charset="-120"/>
+              </a:rPr>
+              <a:t>→  Capped at 8,000, and the delta output ceiling cut to 1,200 tokens</a:t>
+            </a:r>
+            <a:endParaRPr lang="en-US" sz="1050" dirty="0"/>
+          </a:p>
+        </p:txBody>
+      </p:sp>
+      <p:sp>
+        <p:nvSpPr>
+          <p:cNvPr id="30" name="Text 28"/>
+          <p:cNvSpPr/>
+          <p:nvPr/>
+        </p:nvSpPr>
+        <p:spPr>
+          <a:xfrm>
+            <a:off x="566928" y="6053328"/>
+            <a:ext cx="11055096" cy="402336"/>
+          </a:xfrm>
+          <a:prstGeom prst="rect">
+            <a:avLst/>
+          </a:prstGeom>
+          <a:noFill/>
+          <a:ln/>
+        </p:spPr>
+        <p:txBody>
+          <a:bodyPr wrap="square" lIns="0" tIns="0" rIns="0" bIns="0" rtlCol="0" anchor="t"/>
+          <a:lstStyle/>
+          <a:p>
+            <a:pPr marL="0" indent="0">
+              <a:buNone/>
+            </a:pPr>
+            <a:r>
+              <a:rPr lang="en-US" sz="1150" b="1" dirty="0">
+                <a:solidFill>
+                  <a:srgbClr val="1E2761"/>
+                </a:solidFill>
+                <a:latin typeface="Calibri" pitchFamily="34" charset="0"/>
+                <a:ea typeface="Calibri" pitchFamily="34" charset="-122"/>
+                <a:cs typeface="Calibri" pitchFamily="34" charset="-120"/>
+              </a:rPr>
+              <a:t>The seventh was the most instructive:  </a:t>
+            </a:r>
             <a:r>
               <a:rPr lang="en-US" sz="1150" dirty="0">
                 <a:solidFill>
-                  <a:srgbClr val="5B6180"/>
-                </a:solidFill>
-                <a:latin typeface="Calibri" pitchFamily="34" charset="0"/>
-                <a:ea typeface="Calibri" pitchFamily="34" charset="-122"/>
-                <a:cs typeface="Calibri" pitchFamily="34" charset="-120"/>
-              </a:rPr>
-              <a:t>A worked example appeared that was in neither the board nor the transcript.</a:t>
-            </a:r>
-            <a:endParaRPr lang="en-US" sz="1150" dirty="0"/>
-          </a:p>
-        </p:txBody>
-      </p:sp>
-      <p:sp>
-        <p:nvSpPr>
-          <p:cNvPr id="21" name="Text 19"/>
-          <p:cNvSpPr/>
-          <p:nvPr/>
-        </p:nvSpPr>
-        <p:spPr>
-          <a:xfrm>
-            <a:off x="6464808" y="5376672"/>
-            <a:ext cx="4892040" cy="548640"/>
-          </a:xfrm>
-          <a:prstGeom prst="rect">
-            <a:avLst/>
-          </a:prstGeom>
-          <a:noFill/>
-          <a:ln/>
-        </p:spPr>
-        <p:txBody>
-          <a:bodyPr wrap="square" lIns="0" tIns="0" rIns="0" bIns="0" rtlCol="0" anchor="ctr"/>
-          <a:lstStyle/>
-          <a:p>
-            <a:pPr marL="0" indent="0">
-              <a:buNone/>
-            </a:pPr>
-            <a:r>
-              <a:rPr lang="en-US" sz="1150" b="1" dirty="0">
-                <a:solidFill>
-                  <a:srgbClr val="2C6E49"/>
-                </a:solidFill>
-                <a:latin typeface="Calibri" pitchFamily="34" charset="0"/>
-                <a:ea typeface="Calibri" pitchFamily="34" charset="-122"/>
-                <a:cs typeface="Calibri" pitchFamily="34" charset="-120"/>
-              </a:rPr>
-              <a:t>→  The prompt now prohibits any example absent from the captured evidence</a:t>
+                  <a:srgbClr val="1A1D2E"/>
+                </a:solidFill>
+                <a:latin typeface="Calibri" pitchFamily="34" charset="0"/>
+                <a:ea typeface="Calibri" pitchFamily="34" charset="-122"/>
+                <a:cs typeface="Calibri" pitchFamily="34" charset="-120"/>
+              </a:rPr>
+              <a:t>the fixes were written but never deployed, so the live service kept serving the old code. Verifying the deployment is now part of the fix.</a:t>
             </a:r>
             <a:endParaRPr lang="en-US" sz="1150" dirty="0"/>
           </a:p>
@@ -13087,7 +13425,7 @@
         </p:nvSpPr>
         <p:spPr>
           <a:xfrm>
-            <a:off x="566928" y="1783080"/>
+            <a:off x="566928" y="1737360"/>
             <a:ext cx="384048" cy="384048"/>
           </a:xfrm>
           <a:prstGeom prst="ellipse">
@@ -13107,7 +13445,7 @@
         </p:nvSpPr>
         <p:spPr>
           <a:xfrm>
-            <a:off x="566928" y="1783080"/>
+            <a:off x="566928" y="1737360"/>
             <a:ext cx="384048" cy="384048"/>
           </a:xfrm>
           <a:prstGeom prst="rect">
@@ -13146,7 +13484,7 @@
         </p:nvSpPr>
         <p:spPr>
           <a:xfrm>
-            <a:off x="1115568" y="1728216"/>
+            <a:off x="1115568" y="1682496"/>
             <a:ext cx="1920240" cy="384048"/>
           </a:xfrm>
           <a:prstGeom prst="rect">
@@ -13185,7 +13523,7 @@
         </p:nvSpPr>
         <p:spPr>
           <a:xfrm>
-            <a:off x="2852928" y="1728216"/>
+            <a:off x="2852928" y="1682496"/>
             <a:ext cx="4462272" cy="777240"/>
           </a:xfrm>
           <a:prstGeom prst="rect">
@@ -13224,7 +13562,7 @@
         </p:nvSpPr>
         <p:spPr>
           <a:xfrm>
-            <a:off x="566928" y="2807208"/>
+            <a:off x="566928" y="2606040"/>
             <a:ext cx="384048" cy="384048"/>
           </a:xfrm>
           <a:prstGeom prst="ellipse">
@@ -13244,7 +13582,7 @@
         </p:nvSpPr>
         <p:spPr>
           <a:xfrm>
-            <a:off x="566928" y="2807208"/>
+            <a:off x="566928" y="2606040"/>
             <a:ext cx="384048" cy="384048"/>
           </a:xfrm>
           <a:prstGeom prst="rect">
@@ -13283,7 +13621,7 @@
         </p:nvSpPr>
         <p:spPr>
           <a:xfrm>
-            <a:off x="1115568" y="2752344"/>
+            <a:off x="1115568" y="2551176"/>
             <a:ext cx="1920240" cy="384048"/>
           </a:xfrm>
           <a:prstGeom prst="rect">
@@ -13322,7 +13660,7 @@
         </p:nvSpPr>
         <p:spPr>
           <a:xfrm>
-            <a:off x="2852928" y="2752344"/>
+            <a:off x="2852928" y="2551176"/>
             <a:ext cx="4462272" cy="777240"/>
           </a:xfrm>
           <a:prstGeom prst="rect">
@@ -13361,7 +13699,7 @@
         </p:nvSpPr>
         <p:spPr>
           <a:xfrm>
-            <a:off x="566928" y="3831336"/>
+            <a:off x="566928" y="3474720"/>
             <a:ext cx="384048" cy="384048"/>
           </a:xfrm>
           <a:prstGeom prst="ellipse">
@@ -13381,7 +13719,7 @@
         </p:nvSpPr>
         <p:spPr>
           <a:xfrm>
-            <a:off x="566928" y="3831336"/>
+            <a:off x="566928" y="3474720"/>
             <a:ext cx="384048" cy="384048"/>
           </a:xfrm>
           <a:prstGeom prst="rect">
@@ -13420,7 +13758,7 @@
         </p:nvSpPr>
         <p:spPr>
           <a:xfrm>
-            <a:off x="1115568" y="3776472"/>
+            <a:off x="1115568" y="3419856"/>
             <a:ext cx="1920240" cy="384048"/>
           </a:xfrm>
           <a:prstGeom prst="rect">
@@ -13459,7 +13797,7 @@
         </p:nvSpPr>
         <p:spPr>
           <a:xfrm>
-            <a:off x="2852928" y="3776472"/>
+            <a:off x="2852928" y="3419856"/>
             <a:ext cx="4462272" cy="777240"/>
           </a:xfrm>
           <a:prstGeom prst="rect">
@@ -13484,7 +13822,7 @@
                 <a:ea typeface="Calibri" pitchFamily="34" charset="-122"/>
                 <a:cs typeface="Calibri" pitchFamily="34" charset="-120"/>
               </a:rPr>
-              <a:t>Centred pixel difference + fraction of pixels changed, against the last committed state</a:t>
+              <a:t>Centred pixel difference and fraction of pixels changed, against the last committed state</a:t>
             </a:r>
             <a:endParaRPr lang="en-US" sz="1250" dirty="0"/>
           </a:p>
@@ -13498,7 +13836,144 @@
         </p:nvSpPr>
         <p:spPr>
           <a:xfrm>
-            <a:off x="566928" y="4855464"/>
+            <a:off x="566928" y="4343400"/>
+            <a:ext cx="384048" cy="384048"/>
+          </a:xfrm>
+          <a:prstGeom prst="ellipse">
+            <a:avLst/>
+          </a:prstGeom>
+          <a:solidFill>
+            <a:srgbClr val="E8A33D"/>
+          </a:solidFill>
+          <a:ln/>
+        </p:spPr>
+      </p:sp>
+      <p:sp>
+        <p:nvSpPr>
+          <p:cNvPr id="19" name="Text 17"/>
+          <p:cNvSpPr/>
+          <p:nvPr/>
+        </p:nvSpPr>
+        <p:spPr>
+          <a:xfrm>
+            <a:off x="566928" y="4343400"/>
+            <a:ext cx="384048" cy="384048"/>
+          </a:xfrm>
+          <a:prstGeom prst="rect">
+            <a:avLst/>
+          </a:prstGeom>
+          <a:noFill/>
+          <a:ln/>
+        </p:spPr>
+        <p:txBody>
+          <a:bodyPr wrap="square" lIns="0" tIns="0" rIns="0" bIns="0" rtlCol="0" anchor="ctr"/>
+          <a:lstStyle/>
+          <a:p>
+            <a:pPr marL="0" indent="0" algn="ctr">
+              <a:buNone/>
+            </a:pPr>
+            <a:r>
+              <a:rPr lang="en-US" sz="1200" b="1" dirty="0">
+                <a:solidFill>
+                  <a:srgbClr val="FFFFFF"/>
+                </a:solidFill>
+                <a:latin typeface="Calibri" pitchFamily="34" charset="0"/>
+                <a:ea typeface="Calibri" pitchFamily="34" charset="-122"/>
+                <a:cs typeface="Calibri" pitchFamily="34" charset="-120"/>
+              </a:rPr>
+              <a:t>4</a:t>
+            </a:r>
+            <a:endParaRPr lang="en-US" sz="1200" dirty="0"/>
+          </a:p>
+        </p:txBody>
+      </p:sp>
+      <p:sp>
+        <p:nvSpPr>
+          <p:cNvPr id="20" name="Text 18"/>
+          <p:cNvSpPr/>
+          <p:nvPr/>
+        </p:nvSpPr>
+        <p:spPr>
+          <a:xfrm>
+            <a:off x="1115568" y="4288536"/>
+            <a:ext cx="1920240" cy="384048"/>
+          </a:xfrm>
+          <a:prstGeom prst="rect">
+            <a:avLst/>
+          </a:prstGeom>
+          <a:noFill/>
+          <a:ln/>
+        </p:spPr>
+        <p:txBody>
+          <a:bodyPr wrap="square" lIns="0" tIns="0" rIns="0" bIns="0" rtlCol="0" anchor="t"/>
+          <a:lstStyle/>
+          <a:p>
+            <a:pPr marL="0" indent="0">
+              <a:buNone/>
+            </a:pPr>
+            <a:r>
+              <a:rPr lang="en-US" sz="1400" b="1" dirty="0">
+                <a:solidFill>
+                  <a:srgbClr val="1E2761"/>
+                </a:solidFill>
+                <a:latin typeface="Calibri" pitchFamily="34" charset="0"/>
+                <a:ea typeface="Calibri" pitchFamily="34" charset="-122"/>
+                <a:cs typeface="Calibri" pitchFamily="34" charset="-120"/>
+              </a:rPr>
+              <a:t>Settle</a:t>
+            </a:r>
+            <a:endParaRPr lang="en-US" sz="1400" dirty="0"/>
+          </a:p>
+        </p:txBody>
+      </p:sp>
+      <p:sp>
+        <p:nvSpPr>
+          <p:cNvPr id="21" name="Text 19"/>
+          <p:cNvSpPr/>
+          <p:nvPr/>
+        </p:nvSpPr>
+        <p:spPr>
+          <a:xfrm>
+            <a:off x="2852928" y="4288536"/>
+            <a:ext cx="4462272" cy="777240"/>
+          </a:xfrm>
+          <a:prstGeom prst="rect">
+            <a:avLst/>
+          </a:prstGeom>
+          <a:noFill/>
+          <a:ln/>
+        </p:spPr>
+        <p:txBody>
+          <a:bodyPr wrap="square" lIns="0" tIns="0" rIns="0" bIns="0" rtlCol="0" anchor="t"/>
+          <a:lstStyle/>
+          <a:p>
+            <a:pPr marL="0" indent="0">
+              <a:buNone/>
+            </a:pPr>
+            <a:r>
+              <a:rPr lang="en-US" sz="1250" dirty="0">
+                <a:solidFill>
+                  <a:srgbClr val="5B6180"/>
+                </a:solidFill>
+                <a:latin typeface="Calibri" pitchFamily="34" charset="0"/>
+                <a:ea typeface="Calibri" pitchFamily="34" charset="-122"/>
+                <a:cs typeface="Calibri" pitchFamily="34" charset="-120"/>
+              </a:rPr>
+              <a:t>A change must still be there on the next sample. Writing stays; a person does not.</a:t>
+            </a:r>
+            <a:endParaRPr lang="en-US" sz="1250" dirty="0"/>
+          </a:p>
+        </p:txBody>
+      </p:sp>
+      <p:sp>
+        <p:nvSpPr>
+          <p:cNvPr id="22" name="Shape 20"/>
+          <p:cNvSpPr/>
+          <p:nvPr/>
+        </p:nvSpPr>
+        <p:spPr>
+          <a:xfrm>
+            <a:off x="566928" y="5212080"/>
             <a:ext cx="384048" cy="384048"/>
           </a:xfrm>
           <a:prstGeom prst="ellipse">
@@ -13512,13 +13987,13 @@
       </p:sp>
       <p:sp>
         <p:nvSpPr>
-          <p:cNvPr id="19" name="Text 17"/>
-          <p:cNvSpPr/>
-          <p:nvPr/>
-        </p:nvSpPr>
-        <p:spPr>
-          <a:xfrm>
-            <a:off x="566928" y="4855464"/>
+          <p:cNvPr id="23" name="Text 21"/>
+          <p:cNvSpPr/>
+          <p:nvPr/>
+        </p:nvSpPr>
+        <p:spPr>
+          <a:xfrm>
+            <a:off x="566928" y="5212080"/>
             <a:ext cx="384048" cy="384048"/>
           </a:xfrm>
           <a:prstGeom prst="rect">
@@ -13543,7 +14018,7 @@
                 <a:ea typeface="Calibri" pitchFamily="34" charset="-122"/>
                 <a:cs typeface="Calibri" pitchFamily="34" charset="-120"/>
               </a:rPr>
-              <a:t>4</a:t>
+              <a:t>5</a:t>
             </a:r>
             <a:endParaRPr lang="en-US" sz="1200" dirty="0"/>
           </a:p>
@@ -13551,13 +14026,13 @@
       </p:sp>
       <p:sp>
         <p:nvSpPr>
-          <p:cNvPr id="20" name="Text 18"/>
-          <p:cNvSpPr/>
-          <p:nvPr/>
-        </p:nvSpPr>
-        <p:spPr>
-          <a:xfrm>
-            <a:off x="1115568" y="4800600"/>
+          <p:cNvPr id="24" name="Text 22"/>
+          <p:cNvSpPr/>
+          <p:nvPr/>
+        </p:nvSpPr>
+        <p:spPr>
+          <a:xfrm>
+            <a:off x="1115568" y="5157216"/>
             <a:ext cx="1920240" cy="384048"/>
           </a:xfrm>
           <a:prstGeom prst="rect">
@@ -13590,13 +14065,13 @@
       </p:sp>
       <p:sp>
         <p:nvSpPr>
-          <p:cNvPr id="21" name="Text 19"/>
-          <p:cNvSpPr/>
-          <p:nvPr/>
-        </p:nvSpPr>
-        <p:spPr>
-          <a:xfrm>
-            <a:off x="2852928" y="4800600"/>
+          <p:cNvPr id="25" name="Text 23"/>
+          <p:cNvSpPr/>
+          <p:nvPr/>
+        </p:nvSpPr>
+        <p:spPr>
+          <a:xfrm>
+            <a:off x="2852928" y="5157216"/>
             <a:ext cx="4462272" cy="777240"/>
           </a:xfrm>
           <a:prstGeom prst="rect">
@@ -13621,7 +14096,7 @@
                 <a:ea typeface="Calibri" pitchFamily="34" charset="-122"/>
                 <a:cs typeface="Calibri" pitchFamily="34" charset="-120"/>
               </a:rPr>
-              <a:t>Above threshold the frame is sent; below, it is discarded on the phone with no API call</a:t>
+              <a:t>Only a settled change is sent; everything else is discarded on the phone with no API call</a:t>
             </a:r>
             <a:endParaRPr lang="en-US" sz="1250" dirty="0"/>
           </a:p>
@@ -13629,18 +14104,18 @@
       </p:sp>
       <p:sp>
         <p:nvSpPr>
-          <p:cNvPr id="22" name="Shape 20"/>
-          <p:cNvSpPr/>
-          <p:nvPr/>
-        </p:nvSpPr>
-        <p:spPr>
-          <a:xfrm>
-            <a:off x="7772400" y="1783080"/>
-            <a:ext cx="3840480" cy="2240280"/>
+          <p:cNvPr id="26" name="Shape 24"/>
+          <p:cNvSpPr/>
+          <p:nvPr/>
+        </p:nvSpPr>
+        <p:spPr>
+          <a:xfrm>
+            <a:off x="7772400" y="1737360"/>
+            <a:ext cx="3840480" cy="2103120"/>
           </a:xfrm>
           <a:prstGeom prst="roundRect">
             <a:avLst>
-              <a:gd name="adj" fmla="val 3673"/>
+              <a:gd name="adj" fmla="val 3913"/>
             </a:avLst>
           </a:prstGeom>
           <a:solidFill>
@@ -13656,30 +14131,30 @@
       </p:sp>
       <p:sp>
         <p:nvSpPr>
-          <p:cNvPr id="23" name="Text 21"/>
-          <p:cNvSpPr/>
-          <p:nvPr/>
-        </p:nvSpPr>
-        <p:spPr>
-          <a:xfrm>
-            <a:off x="8046720" y="1938528"/>
-            <a:ext cx="3291840" cy="658368"/>
-          </a:xfrm>
-          <a:prstGeom prst="rect">
-            <a:avLst/>
-          </a:prstGeom>
-          <a:noFill/>
-          <a:ln/>
-        </p:spPr>
-        <p:txBody>
-          <a:bodyPr wrap="square" lIns="0" tIns="0" rIns="0" bIns="0" rtlCol="0" anchor="ctr"/>
-          <a:lstStyle/>
-          <a:p>
-            <a:pPr marL="0" indent="0">
-              <a:buNone/>
-            </a:pPr>
-            <a:r>
-              <a:rPr lang="en-US" sz="4000" b="1" dirty="0">
+          <p:cNvPr id="27" name="Text 25"/>
+          <p:cNvSpPr/>
+          <p:nvPr/>
+        </p:nvSpPr>
+        <p:spPr>
+          <a:xfrm>
+            <a:off x="8046720" y="1865376"/>
+            <a:ext cx="3291840" cy="640080"/>
+          </a:xfrm>
+          <a:prstGeom prst="rect">
+            <a:avLst/>
+          </a:prstGeom>
+          <a:noFill/>
+          <a:ln/>
+        </p:spPr>
+        <p:txBody>
+          <a:bodyPr wrap="square" lIns="0" tIns="0" rIns="0" bIns="0" rtlCol="0" anchor="t"/>
+          <a:lstStyle/>
+          <a:p>
+            <a:pPr marL="0" indent="0">
+              <a:buNone/>
+            </a:pPr>
+            <a:r>
+              <a:rPr lang="en-US" sz="3800" b="1" dirty="0">
                 <a:solidFill>
                   <a:srgbClr val="6E7BB5"/>
                 </a:solidFill>
@@ -13689,19 +14164,19 @@
               </a:rPr>
               <a:t>~450</a:t>
             </a:r>
-            <a:endParaRPr lang="en-US" sz="4000" dirty="0"/>
-          </a:p>
-        </p:txBody>
-      </p:sp>
-      <p:sp>
-        <p:nvSpPr>
-          <p:cNvPr id="24" name="Text 22"/>
-          <p:cNvSpPr/>
-          <p:nvPr/>
-        </p:nvSpPr>
-        <p:spPr>
-          <a:xfrm>
-            <a:off x="8046720" y="2578608"/>
+            <a:endParaRPr lang="en-US" sz="3800" dirty="0"/>
+          </a:p>
+        </p:txBody>
+      </p:sp>
+      <p:sp>
+        <p:nvSpPr>
+          <p:cNvPr id="28" name="Text 26"/>
+          <p:cNvSpPr/>
+          <p:nvPr/>
+        </p:nvSpPr>
+        <p:spPr>
+          <a:xfrm>
+            <a:off x="8046720" y="2468880"/>
             <a:ext cx="3291840" cy="274320"/>
           </a:xfrm>
           <a:prstGeom prst="rect">
@@ -13711,7 +14186,7 @@
           <a:ln/>
         </p:spPr>
         <p:txBody>
-          <a:bodyPr wrap="square" lIns="0" tIns="0" rIns="0" bIns="0" rtlCol="0" anchor="ctr"/>
+          <a:bodyPr wrap="square" lIns="0" tIns="0" rIns="0" bIns="0" rtlCol="0" anchor="t"/>
           <a:lstStyle/>
           <a:p>
             <a:pPr marL="0" indent="0">
@@ -13734,30 +14209,30 @@
       </p:sp>
       <p:sp>
         <p:nvSpPr>
-          <p:cNvPr id="25" name="Text 23"/>
-          <p:cNvSpPr/>
-          <p:nvPr/>
-        </p:nvSpPr>
-        <p:spPr>
-          <a:xfrm>
-            <a:off x="8046720" y="2926080"/>
-            <a:ext cx="3291840" cy="566928"/>
-          </a:xfrm>
-          <a:prstGeom prst="rect">
-            <a:avLst/>
-          </a:prstGeom>
-          <a:noFill/>
-          <a:ln/>
-        </p:spPr>
-        <p:txBody>
-          <a:bodyPr wrap="square" lIns="0" tIns="0" rIns="0" bIns="0" rtlCol="0" anchor="ctr"/>
-          <a:lstStyle/>
-          <a:p>
-            <a:pPr marL="0" indent="0">
-              <a:buNone/>
-            </a:pPr>
-            <a:r>
-              <a:rPr lang="en-US" sz="3400" b="1" dirty="0">
+          <p:cNvPr id="29" name="Text 27"/>
+          <p:cNvSpPr/>
+          <p:nvPr/>
+        </p:nvSpPr>
+        <p:spPr>
+          <a:xfrm>
+            <a:off x="8046720" y="2779776"/>
+            <a:ext cx="3291840" cy="548640"/>
+          </a:xfrm>
+          <a:prstGeom prst="rect">
+            <a:avLst/>
+          </a:prstGeom>
+          <a:noFill/>
+          <a:ln/>
+        </p:spPr>
+        <p:txBody>
+          <a:bodyPr wrap="square" lIns="0" tIns="0" rIns="0" bIns="0" rtlCol="0" anchor="t"/>
+          <a:lstStyle/>
+          <a:p>
+            <a:pPr marL="0" indent="0">
+              <a:buNone/>
+            </a:pPr>
+            <a:r>
+              <a:rPr lang="en-US" sz="3200" b="1" dirty="0">
                 <a:solidFill>
                   <a:srgbClr val="E8A33D"/>
                 </a:solidFill>
@@ -13767,19 +14242,19 @@
               </a:rPr>
               <a:t>~40</a:t>
             </a:r>
-            <a:endParaRPr lang="en-US" sz="3400" dirty="0"/>
-          </a:p>
-        </p:txBody>
-      </p:sp>
-      <p:sp>
-        <p:nvSpPr>
-          <p:cNvPr id="26" name="Text 24"/>
-          <p:cNvSpPr/>
-          <p:nvPr/>
-        </p:nvSpPr>
-        <p:spPr>
-          <a:xfrm>
-            <a:off x="8046720" y="3529584"/>
+            <a:endParaRPr lang="en-US" sz="3200" dirty="0"/>
+          </a:p>
+        </p:txBody>
+      </p:sp>
+      <p:sp>
+        <p:nvSpPr>
+          <p:cNvPr id="30" name="Text 28"/>
+          <p:cNvSpPr/>
+          <p:nvPr/>
+        </p:nvSpPr>
+        <p:spPr>
+          <a:xfrm>
+            <a:off x="8046720" y="3328416"/>
             <a:ext cx="3291840" cy="274320"/>
           </a:xfrm>
           <a:prstGeom prst="rect">
@@ -13789,7 +14264,7 @@
           <a:ln/>
         </p:spPr>
         <p:txBody>
-          <a:bodyPr wrap="square" lIns="0" tIns="0" rIns="0" bIns="0" rtlCol="0" anchor="ctr"/>
+          <a:bodyPr wrap="square" lIns="0" tIns="0" rIns="0" bIns="0" rtlCol="0" anchor="t"/>
           <a:lstStyle/>
           <a:p>
             <a:pPr marL="0" indent="0">
@@ -13812,18 +14287,18 @@
       </p:sp>
       <p:sp>
         <p:nvSpPr>
-          <p:cNvPr id="27" name="Shape 25"/>
-          <p:cNvSpPr/>
-          <p:nvPr/>
-        </p:nvSpPr>
-        <p:spPr>
-          <a:xfrm>
-            <a:off x="7772400" y="4224528"/>
-            <a:ext cx="3840480" cy="1691640"/>
+          <p:cNvPr id="31" name="Shape 29"/>
+          <p:cNvSpPr/>
+          <p:nvPr/>
+        </p:nvSpPr>
+        <p:spPr>
+          <a:xfrm>
+            <a:off x="7772400" y="4023360"/>
+            <a:ext cx="3840480" cy="1051560"/>
           </a:xfrm>
           <a:prstGeom prst="roundRect">
             <a:avLst>
-              <a:gd name="adj" fmla="val 4865"/>
+              <a:gd name="adj" fmla="val 7826"/>
             </a:avLst>
           </a:prstGeom>
           <a:solidFill>
@@ -13839,13 +14314,13 @@
       </p:sp>
       <p:sp>
         <p:nvSpPr>
-          <p:cNvPr id="28" name="Text 26"/>
-          <p:cNvSpPr/>
-          <p:nvPr/>
-        </p:nvSpPr>
-        <p:spPr>
-          <a:xfrm>
-            <a:off x="8046720" y="4389120"/>
+          <p:cNvPr id="32" name="Text 30"/>
+          <p:cNvSpPr/>
+          <p:nvPr/>
+        </p:nvSpPr>
+        <p:spPr>
+          <a:xfrm>
+            <a:off x="8046720" y="4160520"/>
             <a:ext cx="3291840" cy="274320"/>
           </a:xfrm>
           <a:prstGeom prst="rect">
@@ -13855,14 +14330,14 @@
           <a:ln/>
         </p:spPr>
         <p:txBody>
-          <a:bodyPr wrap="square" lIns="0" tIns="0" rIns="0" bIns="0" rtlCol="0" anchor="ctr"/>
-          <a:lstStyle/>
-          <a:p>
-            <a:pPr marL="0" indent="0">
-              <a:buNone/>
-            </a:pPr>
-            <a:r>
-              <a:rPr lang="en-US" sz="1300" b="1" dirty="0">
+          <a:bodyPr wrap="square" lIns="0" tIns="0" rIns="0" bIns="0" rtlCol="0" anchor="t"/>
+          <a:lstStyle/>
+          <a:p>
+            <a:pPr marL="0" indent="0">
+              <a:buNone/>
+            </a:pPr>
+            <a:r>
+              <a:rPr lang="en-US" sz="1250" b="1" dirty="0">
                 <a:solidFill>
                   <a:srgbClr val="1E2761"/>
                 </a:solidFill>
@@ -13870,38 +14345,143 @@
                 <a:ea typeface="Calibri" pitchFamily="34" charset="-122"/>
                 <a:cs typeface="Calibri" pitchFamily="34" charset="-120"/>
               </a:rPr>
+              <a:t>Why the settle step</a:t>
+            </a:r>
+            <a:endParaRPr lang="en-US" sz="1250" dirty="0"/>
+          </a:p>
+        </p:txBody>
+      </p:sp>
+      <p:sp>
+        <p:nvSpPr>
+          <p:cNvPr id="33" name="Text 31"/>
+          <p:cNvSpPr/>
+          <p:nvPr/>
+        </p:nvSpPr>
+        <p:spPr>
+          <a:xfrm>
+            <a:off x="8046720" y="4434840"/>
+            <a:ext cx="3291840" cy="548640"/>
+          </a:xfrm>
+          <a:prstGeom prst="rect">
+            <a:avLst/>
+          </a:prstGeom>
+          <a:noFill/>
+          <a:ln/>
+        </p:spPr>
+        <p:txBody>
+          <a:bodyPr wrap="square" lIns="0" tIns="0" rIns="0" bIns="0" rtlCol="0" anchor="t"/>
+          <a:lstStyle/>
+          <a:p>
+            <a:pPr marL="0" indent="0">
+              <a:buNone/>
+            </a:pPr>
+            <a:r>
+              <a:rPr lang="en-US" sz="1100" dirty="0">
+                <a:solidFill>
+                  <a:srgbClr val="5B6180"/>
+                </a:solidFill>
+                <a:latin typeface="Calibri" pitchFamily="34" charset="0"/>
+                <a:ea typeface="Calibri" pitchFamily="34" charset="-122"/>
+                <a:cs typeface="Calibri" pitchFamily="34" charset="-120"/>
+              </a:rPr>
+              <a:t>A teacher walking past changed the frame and triggered an upload. Now movement never survives to the second sample.</a:t>
+            </a:r>
+            <a:endParaRPr lang="en-US" sz="1100" dirty="0"/>
+          </a:p>
+        </p:txBody>
+      </p:sp>
+      <p:sp>
+        <p:nvSpPr>
+          <p:cNvPr id="34" name="Shape 32"/>
+          <p:cNvSpPr/>
+          <p:nvPr/>
+        </p:nvSpPr>
+        <p:spPr>
+          <a:xfrm>
+            <a:off x="7772400" y="5230368"/>
+            <a:ext cx="3840480" cy="1051560"/>
+          </a:xfrm>
+          <a:prstGeom prst="roundRect">
+            <a:avLst>
+              <a:gd name="adj" fmla="val 7826"/>
+            </a:avLst>
+          </a:prstGeom>
+          <a:solidFill>
+            <a:srgbClr val="E8F0FE"/>
+          </a:solidFill>
+          <a:ln w="12700">
+            <a:solidFill>
+              <a:srgbClr val="E2E7F0"/>
+            </a:solidFill>
+            <a:prstDash val="solid"/>
+          </a:ln>
+        </p:spPr>
+      </p:sp>
+      <p:sp>
+        <p:nvSpPr>
+          <p:cNvPr id="35" name="Text 33"/>
+          <p:cNvSpPr/>
+          <p:nvPr/>
+        </p:nvSpPr>
+        <p:spPr>
+          <a:xfrm>
+            <a:off x="8046720" y="5367528"/>
+            <a:ext cx="3291840" cy="274320"/>
+          </a:xfrm>
+          <a:prstGeom prst="rect">
+            <a:avLst/>
+          </a:prstGeom>
+          <a:noFill/>
+          <a:ln/>
+        </p:spPr>
+        <p:txBody>
+          <a:bodyPr wrap="square" lIns="0" tIns="0" rIns="0" bIns="0" rtlCol="0" anchor="t"/>
+          <a:lstStyle/>
+          <a:p>
+            <a:pPr marL="0" indent="0">
+              <a:buNone/>
+            </a:pPr>
+            <a:r>
+              <a:rPr lang="en-US" sz="1250" b="1" dirty="0">
+                <a:solidFill>
+                  <a:srgbClr val="1E2761"/>
+                </a:solidFill>
+                <a:latin typeface="Calibri" pitchFamily="34" charset="0"/>
+                <a:ea typeface="Calibri" pitchFamily="34" charset="-122"/>
+                <a:cs typeface="Calibri" pitchFamily="34" charset="-120"/>
+              </a:rPr>
               <a:t>Two-phase commit</a:t>
             </a:r>
-            <a:endParaRPr lang="en-US" sz="1300" dirty="0"/>
-          </a:p>
-        </p:txBody>
-      </p:sp>
-      <p:sp>
-        <p:nvSpPr>
-          <p:cNvPr id="29" name="Text 27"/>
-          <p:cNvSpPr/>
-          <p:nvPr/>
-        </p:nvSpPr>
-        <p:spPr>
-          <a:xfrm>
-            <a:off x="8046720" y="4700016"/>
-            <a:ext cx="3291840" cy="1097280"/>
-          </a:xfrm>
-          <a:prstGeom prst="rect">
-            <a:avLst/>
-          </a:prstGeom>
-          <a:noFill/>
-          <a:ln/>
-        </p:spPr>
-        <p:txBody>
-          <a:bodyPr wrap="square" lIns="0" tIns="0" rIns="0" bIns="0" rtlCol="0" anchor="ctr"/>
-          <a:lstStyle/>
-          <a:p>
-            <a:pPr marL="0" indent="0">
-              <a:buNone/>
-            </a:pPr>
-            <a:r>
-              <a:rPr lang="en-US" sz="1150" dirty="0">
+            <a:endParaRPr lang="en-US" sz="1250" dirty="0"/>
+          </a:p>
+        </p:txBody>
+      </p:sp>
+      <p:sp>
+        <p:nvSpPr>
+          <p:cNvPr id="36" name="Text 34"/>
+          <p:cNvSpPr/>
+          <p:nvPr/>
+        </p:nvSpPr>
+        <p:spPr>
+          <a:xfrm>
+            <a:off x="8046720" y="5641848"/>
+            <a:ext cx="3291840" cy="548640"/>
+          </a:xfrm>
+          <a:prstGeom prst="rect">
+            <a:avLst/>
+          </a:prstGeom>
+          <a:noFill/>
+          <a:ln/>
+        </p:spPr>
+        <p:txBody>
+          <a:bodyPr wrap="square" lIns="0" tIns="0" rIns="0" bIns="0" rtlCol="0" anchor="t"/>
+          <a:lstStyle/>
+          <a:p>
+            <a:pPr marL="0" indent="0">
+              <a:buNone/>
+            </a:pPr>
+            <a:r>
+              <a:rPr lang="en-US" sz="1100" dirty="0">
                 <a:solidFill>
                   <a:srgbClr val="5B6180"/>
                 </a:solidFill>
@@ -13909,9 +14489,9 @@
                 <a:ea typeface="Calibri" pitchFamily="34" charset="-122"/>
                 <a:cs typeface="Calibri" pitchFamily="34" charset="-120"/>
               </a:rPr>
-              <a:t>The new baseline is adopted only after the note and crops are saved. If extraction fails, the same board change is detected again instead of being lost.</a:t>
-            </a:r>
-            <a:endParaRPr lang="en-US" sz="1150" dirty="0"/>
+              <a:t>The baseline advances only after the note and crops are saved, so a failed extraction is retried, not lost.</a:t>
+            </a:r>
+            <a:endParaRPr lang="en-US" sz="1100" dirty="0"/>
           </a:p>
         </p:txBody>
       </p:sp>

</xml_diff>